<commit_message>
Fix back-edge connector routing in PPTX output
Replace the auto-routed bentConnector3 back-edge (PowerPoint routed it
through the middle of the diagram) with three explicit straight
segments on a vertical rail 50 layout-px right of the rightmost shape,
mirroring svg_debug.py: source right-mid -> (rail, source y) ->
(rail, target y) -> target right-mid. First segment stays attached to
the source shape, last to the target. Forward-edge connectors unchanged.

Co-Authored-By: Claude Fable 5 <noreply@anthropic.com>
</commit_message>
<xml_diff>
--- a/samples/output/flowchart_diagram.pptx
+++ b/samples/output/flowchart_diagram.pptx
@@ -3717,6 +3717,69 @@
           <p:cNvPr id="19" name="Connector 18"/>
           <p:cNvCxnSpPr>
             <a:stCxn id="9" idx="3"/>
+          </p:cNvCxnSpPr>
+          <p:nvPr/>
+        </p:nvCxnSpPr>
+        <p:spPr>
+          <a:xfrm>
+            <a:off x="5653143" y="6094206"/>
+            <a:ext cx="376518" cy="1"/>
+          </a:xfrm>
+          <a:prstGeom prst="line">
+            <a:avLst/>
+          </a:prstGeom>
+          <a:ln w="19050"/>
+        </p:spPr>
+        <p:style>
+          <a:lnRef idx="2">
+            <a:schemeClr val="accent1"/>
+          </a:lnRef>
+          <a:fillRef idx="0">
+            <a:schemeClr val="accent1"/>
+          </a:fillRef>
+          <a:effectRef idx="1">
+            <a:schemeClr val="accent1"/>
+          </a:effectRef>
+          <a:fontRef idx="minor">
+            <a:schemeClr val="tx1"/>
+          </a:fontRef>
+        </p:style>
+      </p:cxnSp>
+      <p:cxnSp>
+        <p:nvCxnSpPr>
+          <p:cNvPr id="20" name="Connector 19"/>
+          <p:cNvCxnSpPr/>
+          <p:nvPr/>
+        </p:nvCxnSpPr>
+        <p:spPr>
+          <a:xfrm flipV="1">
+            <a:off x="6029661" y="3985708"/>
+            <a:ext cx="0" cy="2108499"/>
+          </a:xfrm>
+          <a:prstGeom prst="line">
+            <a:avLst/>
+          </a:prstGeom>
+          <a:ln w="19050"/>
+        </p:spPr>
+        <p:style>
+          <a:lnRef idx="2">
+            <a:schemeClr val="accent1"/>
+          </a:lnRef>
+          <a:fillRef idx="0">
+            <a:schemeClr val="accent1"/>
+          </a:fillRef>
+          <a:effectRef idx="1">
+            <a:schemeClr val="accent1"/>
+          </a:effectRef>
+          <a:fontRef idx="minor">
+            <a:schemeClr val="tx1"/>
+          </a:fontRef>
+        </p:style>
+      </p:cxnSp>
+      <p:cxnSp>
+        <p:nvCxnSpPr>
+          <p:cNvPr id="21" name="Connector 20"/>
+          <p:cNvCxnSpPr>
             <a:endCxn id="5" idx="3"/>
           </p:cNvCxnSpPr>
           <p:nvPr/>
@@ -3724,9 +3787,9 @@
         <p:spPr>
           <a:xfrm flipH="1" flipV="1">
             <a:off x="3921161" y="3985707"/>
-            <a:ext cx="1731982" cy="2108499"/>
-          </a:xfrm>
-          <a:prstGeom prst="bentConnector3">
+            <a:ext cx="2108500" cy="1"/>
+          </a:xfrm>
+          <a:prstGeom prst="line">
             <a:avLst/>
           </a:prstGeom>
           <a:ln w="19050"/>

</xml_diff>

<commit_message>
Make back-edge a single fully-attached bent connector (PPTX + DOCX)
The rail was 3 stitched straight segments with fixed waypoint
coordinates; only the outer ends were attached, so dragging a shape
left the middle of the loop floating in both PowerPoint and Word.

Replace with ONE bentConnector3 per back-edge, attached at both ends
(begin/end_connect in pptx, stCxn/endCxn in docx, right side idx 3),
with an explicit adj1 adjustment expressing the vertical rail as a
ratio of the horizontal span between the connection points (negative =
outside the bbox, right of the source). Office recomputes the whole
bent path from live shape positions on drag. adj computation shared
via pptx_shapes.back_edge_rail_adj(); stitched-segment code removed.

Tests assert the back-edge is a single shape with both ends attached
in both formats; 51 passing.

Co-Authored-By: Claude Fable 5 <noreply@anthropic.com>
</commit_message>
<xml_diff>
--- a/samples/output/flowchart_diagram.pptx
+++ b/samples/output/flowchart_diagram.pptx
@@ -3717,69 +3717,6 @@
           <p:cNvPr id="19" name="Connector 18"/>
           <p:cNvCxnSpPr>
             <a:stCxn id="9" idx="3"/>
-          </p:cNvCxnSpPr>
-          <p:nvPr/>
-        </p:nvCxnSpPr>
-        <p:spPr>
-          <a:xfrm>
-            <a:off x="5653143" y="6094206"/>
-            <a:ext cx="376518" cy="1"/>
-          </a:xfrm>
-          <a:prstGeom prst="line">
-            <a:avLst/>
-          </a:prstGeom>
-          <a:ln w="19050"/>
-        </p:spPr>
-        <p:style>
-          <a:lnRef idx="2">
-            <a:schemeClr val="accent1"/>
-          </a:lnRef>
-          <a:fillRef idx="0">
-            <a:schemeClr val="accent1"/>
-          </a:fillRef>
-          <a:effectRef idx="1">
-            <a:schemeClr val="accent1"/>
-          </a:effectRef>
-          <a:fontRef idx="minor">
-            <a:schemeClr val="tx1"/>
-          </a:fontRef>
-        </p:style>
-      </p:cxnSp>
-      <p:cxnSp>
-        <p:nvCxnSpPr>
-          <p:cNvPr id="20" name="Connector 19"/>
-          <p:cNvCxnSpPr/>
-          <p:nvPr/>
-        </p:nvCxnSpPr>
-        <p:spPr>
-          <a:xfrm flipV="1">
-            <a:off x="6029661" y="3985708"/>
-            <a:ext cx="0" cy="2108499"/>
-          </a:xfrm>
-          <a:prstGeom prst="line">
-            <a:avLst/>
-          </a:prstGeom>
-          <a:ln w="19050"/>
-        </p:spPr>
-        <p:style>
-          <a:lnRef idx="2">
-            <a:schemeClr val="accent1"/>
-          </a:lnRef>
-          <a:fillRef idx="0">
-            <a:schemeClr val="accent1"/>
-          </a:fillRef>
-          <a:effectRef idx="1">
-            <a:schemeClr val="accent1"/>
-          </a:effectRef>
-          <a:fontRef idx="minor">
-            <a:schemeClr val="tx1"/>
-          </a:fontRef>
-        </p:style>
-      </p:cxnSp>
-      <p:cxnSp>
-        <p:nvCxnSpPr>
-          <p:cNvPr id="21" name="Connector 20"/>
-          <p:cNvCxnSpPr>
             <a:endCxn id="5" idx="3"/>
           </p:cNvCxnSpPr>
           <p:nvPr/>
@@ -3787,10 +3724,12 @@
         <p:spPr>
           <a:xfrm flipH="1" flipV="1">
             <a:off x="3921161" y="3985707"/>
-            <a:ext cx="2108500" cy="1"/>
+            <a:ext cx="1731982" cy="2108499"/>
           </a:xfrm>
-          <a:prstGeom prst="line">
-            <a:avLst/>
+          <a:prstGeom prst="bentConnector3">
+            <a:avLst>
+              <a:gd name="adj1" fmla="val -21739"/>
+            </a:avLst>
           </a:prstGeom>
           <a:ln w="19050"/>
         </p:spPr>

</xml_diff>